<commit_message>
Restitution : diapositive des coulisses et précisions sur le modèle
- Nouvelle diapositive 10 : parcours des données (nettoyage, base, API,
  résultats) et opérations de l'API ouvertes à tous ou protégées par clé
- Diapositive 8 : question posée au modèle et mention du machine learning
- Semaine 7 des réponses mise à jour (11 diapositives)

Co-Authored-By: Claude Opus 5.5 <noreply@anthropic.com>
</commit_message>
<xml_diff>
--- a/docs/restitution_irve.pptx
+++ b/docs/restitution_irve.pptx
@@ -15,6 +15,7 @@
     <p:sldId id="263" r:id="rId15"/>
     <p:sldId id="264" r:id="rId16"/>
     <p:sldId id="265" r:id="rId17"/>
+    <p:sldId id="266" r:id="rId18"/>
   </p:sldIdLst>
   <p:sldSz cx="12191695" cy="6858000" type="screen4x3"/>
   <p:notesSz cx="6858000" cy="9144000"/>
@@ -1154,6 +1155,76 @@
           <a:lstStyle/>
           <a:p>
             <a:r>
+              <a:t>Un mot sur les coulisses, car ces résultats ne sortent pas tels quels des données publiques. Au départ, 227 000 lignes, avec beaucoup de doublons et d'erreurs : j'ai supprimé 60 000 doublons et rattaché chaque borne à sa commune grâce à sa position. J'ai rangé les données dans une base de 6 tables reliées entre elles. Puis j'ai construit une API : c'est comme un guichet. Tout le monde peut consulter les données, mais seules les personnes munies d'une clé peuvent les modifier : consulter les chiffres, les communes, les stations ou les bornes est ouvert à tous ; ajouter, corriger ou supprimer une borne demande la clé, et chaque demande est vérifiée. Enfin, ces données alimentent le tableau de bord et le modèle de prédiction.</a:t>
+            </a:r>
+          </a:p>
+        </p:txBody>
+      </p:sp>
+      <p:sp>
+        <p:nvSpPr>
+          <p:cNvPr id="4" name="Slide Number Placeholder 3"/>
+          <p:cNvSpPr>
+            <a:spLocks noGrp="1"/>
+          </p:cNvSpPr>
+          <p:nvPr>
+            <p:ph type="sldNum" idx="5" sz="quarter"/>
+          </p:nvPr>
+        </p:nvSpPr>
+        <p:spPr/>
+      </p:sp>
+    </p:spTree>
+  </p:cSld>
+  <p:clrMapOvr>
+    <a:masterClrMapping/>
+  </p:clrMapOvr>
+</p:notes>
+</file>
+
+<file path=ppt/notesSlides/notesSlide11.xml><?xml version="1.0" encoding="utf-8"?>
+<p:notes xmlns:a="http://schemas.openxmlformats.org/drawingml/2006/main" xmlns:p="http://schemas.openxmlformats.org/presentationml/2006/main" xmlns:r="http://schemas.openxmlformats.org/officeDocument/2006/relationships">
+  <p:cSld>
+    <p:spTree>
+      <p:nvGrpSpPr>
+        <p:cNvPr id="1" name=""/>
+        <p:cNvGrpSpPr/>
+        <p:nvPr/>
+      </p:nvGrpSpPr>
+      <p:grpSpPr>
+        <a:xfrm>
+          <a:off x="0" y="0"/>
+          <a:ext cx="0" cy="0"/>
+          <a:chOff x="0" y="0"/>
+          <a:chExt cx="0" cy="0"/>
+        </a:xfrm>
+      </p:grpSpPr>
+      <p:sp>
+        <p:nvSpPr>
+          <p:cNvPr id="2" name="Slide Image Placeholder 1"/>
+          <p:cNvSpPr>
+            <a:spLocks noGrp="1"/>
+          </p:cNvSpPr>
+          <p:nvPr>
+            <p:ph type="sldImg" idx="2"/>
+          </p:nvPr>
+        </p:nvSpPr>
+        <p:spPr/>
+      </p:sp>
+      <p:sp>
+        <p:nvSpPr>
+          <p:cNvPr id="3" name="Notes Placeholder 2"/>
+          <p:cNvSpPr>
+            <a:spLocks noGrp="1"/>
+          </p:cNvSpPr>
+          <p:nvPr>
+            <p:ph type="body" idx="3" sz="quarter"/>
+          </p:nvPr>
+        </p:nvSpPr>
+        <p:spPr/>
+        <p:txBody>
+          <a:bodyPr/>
+          <a:lstStyle/>
+          <a:p>
+            <a:r>
               <a:t>Pour finir, l'honnêteté sur ce que les données permettent de dire. Ce qui est solide : la carte des déserts, le manque de recharge rapide outre-mer, et l'accélération du déploiement. Ce qui est à nuancer : je mesure les bornes, pas leur utilisation ; le fichier public est incomplet, avec 17 % de bornes de moins que le baromètre national ; et les distances sont mesurées à vol d'oiseau. En résumé : la France est bien équipée en moyenne, mais l'outre-mer, quelques villages isolés et des bourgs périurbains restent à l'écart. Merci de votre attention, je suis à votre disposition pour vos questions.</a:t>
             </a:r>
           </a:p>
@@ -1644,7 +1715,7 @@
           <a:lstStyle/>
           <a:p>
             <a:r>
-              <a:t>J'ai ensuite entraîné un modèle de prédiction : à partir du profil d'une commune, peut-on deviner si elle a une borne ? Résultat très net : c'est la taille qui décide. Un village de 100 habitants a 3 % de chances d'être équipé, une ville de 5 000 habitants 91 %. Le modèle sert surtout à repérer les exceptions : 557 communes, 1,6 million d'habitants, qui devraient avoir une borne et n'en ont pas. Ce sont surtout des bourgs en périphérie des villes, comme Thorigny-sur-Marne, 10 000 habitants, sans borne, alors que la plus proche est à un peu plus d'un kilomètre.</a:t>
+              <a:t>J'ai ensuite utilisé le machine learning, un modèle de prédiction : à partir du profil d'une commune, peut-on deviner si elle a une borne ? Résultat très net : c'est la taille qui décide. Un village de 100 habitants a 3 % de chances d'être équipé, une ville de 5 000 habitants 91 %. Le modèle sert surtout à repérer les exceptions : 557 communes, 1,6 million d'habitants, qui devraient avoir une borne et n'en ont pas. Ce sont surtout des bourgs en périphérie des villes, comme Thorigny-sur-Marne, 10 000 habitants, sans borne, alors que la plus proche est à un peu plus d'un kilomètre.</a:t>
             </a:r>
           </a:p>
         </p:txBody>
@@ -4882,6 +4953,1350 @@
     <p:bg>
       <p:bgPr>
         <a:solidFill>
+          <a:srgbClr val="FFFFFF"/>
+        </a:solidFill>
+        <a:effectLst/>
+      </p:bgPr>
+    </p:bg>
+    <p:spTree>
+      <p:nvGrpSpPr>
+        <p:cNvPr id="1" name=""/>
+        <p:cNvGrpSpPr/>
+        <p:nvPr/>
+      </p:nvGrpSpPr>
+      <p:grpSpPr/>
+      <p:sp>
+        <p:nvSpPr>
+          <p:cNvPr id="2" name="Titre"/>
+          <p:cNvSpPr txBox="1"/>
+          <p:nvPr/>
+        </p:nvSpPr>
+        <p:spPr>
+          <a:xfrm>
+            <a:off x="548640" y="411480"/>
+            <a:ext cx="11064240" cy="868680"/>
+          </a:xfrm>
+          <a:prstGeom prst="rect">
+            <a:avLst/>
+          </a:prstGeom>
+          <a:noFill/>
+        </p:spPr>
+        <p:txBody>
+          <a:bodyPr wrap="square" lIns="0" rIns="0" tIns="0" bIns="0" anchor="ctr">
+            <a:spAutoFit/>
+          </a:bodyPr>
+          <a:lstStyle/>
+          <a:p>
+            <a:pPr algn="l"/>
+            <a:r>
+              <a:rPr sz="3200" b="1" i="0">
+                <a:solidFill>
+                  <a:srgbClr val="14213D"/>
+                </a:solidFill>
+                <a:latin typeface="Cambria"/>
+              </a:rPr>
+              <a:t>Les coulisses : de la donnée brute au tableau de bord</a:t>
+            </a:r>
+          </a:p>
+        </p:txBody>
+      </p:sp>
+      <p:sp>
+        <p:nvSpPr>
+          <p:cNvPr id="3" name="Source"/>
+          <p:cNvSpPr txBox="1"/>
+          <p:nvPr/>
+        </p:nvSpPr>
+        <p:spPr>
+          <a:xfrm>
+            <a:off x="548640" y="6400800"/>
+            <a:ext cx="9601200" cy="274320"/>
+          </a:xfrm>
+          <a:prstGeom prst="rect">
+            <a:avLst/>
+          </a:prstGeom>
+          <a:noFill/>
+        </p:spPr>
+        <p:txBody>
+          <a:bodyPr wrap="square" lIns="0" rIns="0" tIns="0" bIns="0" anchor="t">
+            <a:spAutoFit/>
+          </a:bodyPr>
+          <a:lstStyle/>
+          <a:p>
+            <a:pPr algn="l"/>
+            <a:r>
+              <a:rPr sz="1000" b="0" i="0">
+                <a:solidFill>
+                  <a:srgbClr val="5B6370"/>
+                </a:solidFill>
+                <a:latin typeface="Calibri"/>
+              </a:rPr>
+              <a:t>Sources : fichier consolidé IRVE (data.gouv.fr, 31/08/2026) ; population : Base Adresse Nationale</a:t>
+            </a:r>
+          </a:p>
+        </p:txBody>
+      </p:sp>
+      <p:sp>
+        <p:nvSpPr>
+          <p:cNvPr id="4" name="Numéro"/>
+          <p:cNvSpPr txBox="1"/>
+          <p:nvPr/>
+        </p:nvSpPr>
+        <p:spPr>
+          <a:xfrm>
+            <a:off x="11155680" y="6400800"/>
+            <a:ext cx="502920" cy="274320"/>
+          </a:xfrm>
+          <a:prstGeom prst="rect">
+            <a:avLst/>
+          </a:prstGeom>
+          <a:noFill/>
+        </p:spPr>
+        <p:txBody>
+          <a:bodyPr wrap="square" lIns="0" rIns="0" tIns="0" bIns="0" anchor="t">
+            <a:spAutoFit/>
+          </a:bodyPr>
+          <a:lstStyle/>
+          <a:p>
+            <a:pPr algn="r"/>
+            <a:r>
+              <a:rPr sz="1000" b="0" i="0">
+                <a:solidFill>
+                  <a:srgbClr val="5B6370"/>
+                </a:solidFill>
+                <a:latin typeface="Calibri"/>
+              </a:rPr>
+              <a:t>10</a:t>
+            </a:r>
+          </a:p>
+        </p:txBody>
+      </p:sp>
+      <p:sp>
+        <p:nvSpPr>
+          <p:cNvPr id="5" name="Rounded Rectangle 4"/>
+          <p:cNvSpPr/>
+          <p:nvPr/>
+        </p:nvSpPr>
+        <p:spPr>
+          <a:xfrm>
+            <a:off x="548640" y="1554480"/>
+            <a:ext cx="1965960" cy="2423160"/>
+          </a:xfrm>
+          <a:prstGeom prst="roundRect">
+            <a:avLst>
+              <a:gd name="adj" fmla="val 8000"/>
+            </a:avLst>
+          </a:prstGeom>
+          <a:solidFill>
+            <a:srgbClr val="F1F4F8"/>
+          </a:solidFill>
+          <a:ln>
+            <a:noFill/>
+          </a:ln>
+          <a:effectLst/>
+        </p:spPr>
+        <p:style>
+          <a:lnRef idx="1">
+            <a:schemeClr val="accent1"/>
+          </a:lnRef>
+          <a:fillRef idx="3">
+            <a:schemeClr val="accent1"/>
+          </a:fillRef>
+          <a:effectRef idx="2">
+            <a:schemeClr val="accent1"/>
+          </a:effectRef>
+          <a:fontRef idx="minor">
+            <a:schemeClr val="lt1"/>
+          </a:fontRef>
+        </p:style>
+        <p:txBody>
+          <a:bodyPr rtlCol="0" anchor="ctr"/>
+          <a:lstStyle/>
+          <a:p>
+            <a:pPr algn="ctr"/>
+          </a:p>
+        </p:txBody>
+      </p:sp>
+      <p:sp>
+        <p:nvSpPr>
+          <p:cNvPr id="6" name="TextBox 5"/>
+          <p:cNvSpPr txBox="1"/>
+          <p:nvPr/>
+        </p:nvSpPr>
+        <p:spPr>
+          <a:xfrm>
+            <a:off x="731520" y="1737360"/>
+            <a:ext cx="1600200" cy="411480"/>
+          </a:xfrm>
+          <a:prstGeom prst="rect">
+            <a:avLst/>
+          </a:prstGeom>
+          <a:noFill/>
+        </p:spPr>
+        <p:txBody>
+          <a:bodyPr wrap="square" lIns="0" rIns="0" tIns="0" bIns="0" anchor="t">
+            <a:spAutoFit/>
+          </a:bodyPr>
+          <a:lstStyle/>
+          <a:p>
+            <a:pPr algn="l"/>
+            <a:r>
+              <a:rPr sz="1200" b="1" i="0">
+                <a:solidFill>
+                  <a:srgbClr val="5B6370"/>
+                </a:solidFill>
+                <a:latin typeface="Calibri"/>
+              </a:rPr>
+              <a:t>DONNÉES BRUTES</a:t>
+            </a:r>
+          </a:p>
+        </p:txBody>
+      </p:sp>
+      <p:sp>
+        <p:nvSpPr>
+          <p:cNvPr id="7" name="TextBox 6"/>
+          <p:cNvSpPr txBox="1"/>
+          <p:nvPr/>
+        </p:nvSpPr>
+        <p:spPr>
+          <a:xfrm>
+            <a:off x="731520" y="2148840"/>
+            <a:ext cx="1600200" cy="685800"/>
+          </a:xfrm>
+          <a:prstGeom prst="rect">
+            <a:avLst/>
+          </a:prstGeom>
+          <a:noFill/>
+        </p:spPr>
+        <p:txBody>
+          <a:bodyPr wrap="square" lIns="0" rIns="0" tIns="0" bIns="0" anchor="t">
+            <a:spAutoFit/>
+          </a:bodyPr>
+          <a:lstStyle/>
+          <a:p>
+            <a:pPr algn="l"/>
+            <a:r>
+              <a:rPr sz="2600" b="1" i="0">
+                <a:solidFill>
+                  <a:srgbClr val="14213D"/>
+                </a:solidFill>
+                <a:latin typeface="Calibri"/>
+              </a:rPr>
+              <a:t>227 000</a:t>
+            </a:r>
+          </a:p>
+        </p:txBody>
+      </p:sp>
+      <p:sp>
+        <p:nvSpPr>
+          <p:cNvPr id="8" name="TextBox 7"/>
+          <p:cNvSpPr txBox="1"/>
+          <p:nvPr/>
+        </p:nvSpPr>
+        <p:spPr>
+          <a:xfrm>
+            <a:off x="731520" y="2834640"/>
+            <a:ext cx="1600200" cy="1097280"/>
+          </a:xfrm>
+          <a:prstGeom prst="rect">
+            <a:avLst/>
+          </a:prstGeom>
+          <a:noFill/>
+        </p:spPr>
+        <p:txBody>
+          <a:bodyPr wrap="square" lIns="0" rIns="0" tIns="0" bIns="0" anchor="t">
+            <a:spAutoFit/>
+          </a:bodyPr>
+          <a:lstStyle/>
+          <a:p>
+            <a:pPr algn="l"/>
+            <a:r>
+              <a:rPr sz="1400" b="0" i="0">
+                <a:solidFill>
+                  <a:srgbClr val="1F2937"/>
+                </a:solidFill>
+                <a:latin typeface="Calibri"/>
+              </a:rPr>
+              <a:t>lignes, 2 sources publiques : bornes et population</a:t>
+            </a:r>
+          </a:p>
+        </p:txBody>
+      </p:sp>
+      <p:sp>
+        <p:nvSpPr>
+          <p:cNvPr id="9" name="Chevron 8"/>
+          <p:cNvSpPr/>
+          <p:nvPr/>
+        </p:nvSpPr>
+        <p:spPr>
+          <a:xfrm>
+            <a:off x="2569464" y="2606040"/>
+            <a:ext cx="201168" cy="310896"/>
+          </a:xfrm>
+          <a:prstGeom prst="chevron">
+            <a:avLst/>
+          </a:prstGeom>
+          <a:solidFill>
+            <a:srgbClr val="5B6370"/>
+          </a:solidFill>
+          <a:ln>
+            <a:noFill/>
+          </a:ln>
+          <a:effectLst/>
+        </p:spPr>
+        <p:style>
+          <a:lnRef idx="1">
+            <a:schemeClr val="accent1"/>
+          </a:lnRef>
+          <a:fillRef idx="3">
+            <a:schemeClr val="accent1"/>
+          </a:fillRef>
+          <a:effectRef idx="2">
+            <a:schemeClr val="accent1"/>
+          </a:effectRef>
+          <a:fontRef idx="minor">
+            <a:schemeClr val="lt1"/>
+          </a:fontRef>
+        </p:style>
+        <p:txBody>
+          <a:bodyPr rtlCol="0" anchor="ctr"/>
+          <a:lstStyle/>
+          <a:p>
+            <a:pPr algn="ctr"/>
+          </a:p>
+        </p:txBody>
+      </p:sp>
+      <p:sp>
+        <p:nvSpPr>
+          <p:cNvPr id="10" name="Rounded Rectangle 9"/>
+          <p:cNvSpPr/>
+          <p:nvPr/>
+        </p:nvSpPr>
+        <p:spPr>
+          <a:xfrm>
+            <a:off x="2825496" y="1554480"/>
+            <a:ext cx="1965960" cy="2423160"/>
+          </a:xfrm>
+          <a:prstGeom prst="roundRect">
+            <a:avLst>
+              <a:gd name="adj" fmla="val 8000"/>
+            </a:avLst>
+          </a:prstGeom>
+          <a:solidFill>
+            <a:srgbClr val="F1F4F8"/>
+          </a:solidFill>
+          <a:ln>
+            <a:noFill/>
+          </a:ln>
+          <a:effectLst/>
+        </p:spPr>
+        <p:style>
+          <a:lnRef idx="1">
+            <a:schemeClr val="accent1"/>
+          </a:lnRef>
+          <a:fillRef idx="3">
+            <a:schemeClr val="accent1"/>
+          </a:fillRef>
+          <a:effectRef idx="2">
+            <a:schemeClr val="accent1"/>
+          </a:effectRef>
+          <a:fontRef idx="minor">
+            <a:schemeClr val="lt1"/>
+          </a:fontRef>
+        </p:style>
+        <p:txBody>
+          <a:bodyPr rtlCol="0" anchor="ctr"/>
+          <a:lstStyle/>
+          <a:p>
+            <a:pPr algn="ctr"/>
+          </a:p>
+        </p:txBody>
+      </p:sp>
+      <p:sp>
+        <p:nvSpPr>
+          <p:cNvPr id="11" name="TextBox 10"/>
+          <p:cNvSpPr txBox="1"/>
+          <p:nvPr/>
+        </p:nvSpPr>
+        <p:spPr>
+          <a:xfrm>
+            <a:off x="3008376" y="1737360"/>
+            <a:ext cx="1600200" cy="411480"/>
+          </a:xfrm>
+          <a:prstGeom prst="rect">
+            <a:avLst/>
+          </a:prstGeom>
+          <a:noFill/>
+        </p:spPr>
+        <p:txBody>
+          <a:bodyPr wrap="square" lIns="0" rIns="0" tIns="0" bIns="0" anchor="t">
+            <a:spAutoFit/>
+          </a:bodyPr>
+          <a:lstStyle/>
+          <a:p>
+            <a:pPr algn="l"/>
+            <a:r>
+              <a:rPr sz="1200" b="1" i="0">
+                <a:solidFill>
+                  <a:srgbClr val="5B6370"/>
+                </a:solidFill>
+                <a:latin typeface="Calibri"/>
+              </a:rPr>
+              <a:t>NETTOYAGE</a:t>
+            </a:r>
+          </a:p>
+        </p:txBody>
+      </p:sp>
+      <p:sp>
+        <p:nvSpPr>
+          <p:cNvPr id="12" name="TextBox 11"/>
+          <p:cNvSpPr txBox="1"/>
+          <p:nvPr/>
+        </p:nvSpPr>
+        <p:spPr>
+          <a:xfrm>
+            <a:off x="3008376" y="2148840"/>
+            <a:ext cx="1600200" cy="685800"/>
+          </a:xfrm>
+          <a:prstGeom prst="rect">
+            <a:avLst/>
+          </a:prstGeom>
+          <a:noFill/>
+        </p:spPr>
+        <p:txBody>
+          <a:bodyPr wrap="square" lIns="0" rIns="0" tIns="0" bIns="0" anchor="t">
+            <a:spAutoFit/>
+          </a:bodyPr>
+          <a:lstStyle/>
+          <a:p>
+            <a:pPr algn="l"/>
+            <a:r>
+              <a:rPr sz="2600" b="1" i="0">
+                <a:solidFill>
+                  <a:srgbClr val="2A78D6"/>
+                </a:solidFill>
+                <a:latin typeface="Calibri"/>
+              </a:rPr>
+              <a:t>166 430</a:t>
+            </a:r>
+          </a:p>
+        </p:txBody>
+      </p:sp>
+      <p:sp>
+        <p:nvSpPr>
+          <p:cNvPr id="13" name="TextBox 12"/>
+          <p:cNvSpPr txBox="1"/>
+          <p:nvPr/>
+        </p:nvSpPr>
+        <p:spPr>
+          <a:xfrm>
+            <a:off x="3008376" y="2834640"/>
+            <a:ext cx="1600200" cy="1097280"/>
+          </a:xfrm>
+          <a:prstGeom prst="rect">
+            <a:avLst/>
+          </a:prstGeom>
+          <a:noFill/>
+        </p:spPr>
+        <p:txBody>
+          <a:bodyPr wrap="square" lIns="0" rIns="0" tIns="0" bIns="0" anchor="t">
+            <a:spAutoFit/>
+          </a:bodyPr>
+          <a:lstStyle/>
+          <a:p>
+            <a:pPr algn="l"/>
+            <a:r>
+              <a:rPr sz="1400" b="0" i="0">
+                <a:solidFill>
+                  <a:srgbClr val="1F2937"/>
+                </a:solidFill>
+                <a:latin typeface="Calibri"/>
+              </a:rPr>
+              <a:t>bornes après 60 000 doublons retirés, chacune rattachée à sa commune</a:t>
+            </a:r>
+          </a:p>
+        </p:txBody>
+      </p:sp>
+      <p:sp>
+        <p:nvSpPr>
+          <p:cNvPr id="14" name="Chevron 13"/>
+          <p:cNvSpPr/>
+          <p:nvPr/>
+        </p:nvSpPr>
+        <p:spPr>
+          <a:xfrm>
+            <a:off x="4846320" y="2606040"/>
+            <a:ext cx="201168" cy="310896"/>
+          </a:xfrm>
+          <a:prstGeom prst="chevron">
+            <a:avLst/>
+          </a:prstGeom>
+          <a:solidFill>
+            <a:srgbClr val="5B6370"/>
+          </a:solidFill>
+          <a:ln>
+            <a:noFill/>
+          </a:ln>
+          <a:effectLst/>
+        </p:spPr>
+        <p:style>
+          <a:lnRef idx="1">
+            <a:schemeClr val="accent1"/>
+          </a:lnRef>
+          <a:fillRef idx="3">
+            <a:schemeClr val="accent1"/>
+          </a:fillRef>
+          <a:effectRef idx="2">
+            <a:schemeClr val="accent1"/>
+          </a:effectRef>
+          <a:fontRef idx="minor">
+            <a:schemeClr val="lt1"/>
+          </a:fontRef>
+        </p:style>
+        <p:txBody>
+          <a:bodyPr rtlCol="0" anchor="ctr"/>
+          <a:lstStyle/>
+          <a:p>
+            <a:pPr algn="ctr"/>
+          </a:p>
+        </p:txBody>
+      </p:sp>
+      <p:sp>
+        <p:nvSpPr>
+          <p:cNvPr id="15" name="Rounded Rectangle 14"/>
+          <p:cNvSpPr/>
+          <p:nvPr/>
+        </p:nvSpPr>
+        <p:spPr>
+          <a:xfrm>
+            <a:off x="5102351" y="1554480"/>
+            <a:ext cx="1965960" cy="2423160"/>
+          </a:xfrm>
+          <a:prstGeom prst="roundRect">
+            <a:avLst>
+              <a:gd name="adj" fmla="val 8000"/>
+            </a:avLst>
+          </a:prstGeom>
+          <a:solidFill>
+            <a:srgbClr val="F1F4F8"/>
+          </a:solidFill>
+          <a:ln>
+            <a:noFill/>
+          </a:ln>
+          <a:effectLst/>
+        </p:spPr>
+        <p:style>
+          <a:lnRef idx="1">
+            <a:schemeClr val="accent1"/>
+          </a:lnRef>
+          <a:fillRef idx="3">
+            <a:schemeClr val="accent1"/>
+          </a:fillRef>
+          <a:effectRef idx="2">
+            <a:schemeClr val="accent1"/>
+          </a:effectRef>
+          <a:fontRef idx="minor">
+            <a:schemeClr val="lt1"/>
+          </a:fontRef>
+        </p:style>
+        <p:txBody>
+          <a:bodyPr rtlCol="0" anchor="ctr"/>
+          <a:lstStyle/>
+          <a:p>
+            <a:pPr algn="ctr"/>
+          </a:p>
+        </p:txBody>
+      </p:sp>
+      <p:sp>
+        <p:nvSpPr>
+          <p:cNvPr id="16" name="TextBox 15"/>
+          <p:cNvSpPr txBox="1"/>
+          <p:nvPr/>
+        </p:nvSpPr>
+        <p:spPr>
+          <a:xfrm>
+            <a:off x="5285231" y="1737360"/>
+            <a:ext cx="1600200" cy="411480"/>
+          </a:xfrm>
+          <a:prstGeom prst="rect">
+            <a:avLst/>
+          </a:prstGeom>
+          <a:noFill/>
+        </p:spPr>
+        <p:txBody>
+          <a:bodyPr wrap="square" lIns="0" rIns="0" tIns="0" bIns="0" anchor="t">
+            <a:spAutoFit/>
+          </a:bodyPr>
+          <a:lstStyle/>
+          <a:p>
+            <a:pPr algn="l"/>
+            <a:r>
+              <a:rPr sz="1200" b="1" i="0">
+                <a:solidFill>
+                  <a:srgbClr val="5B6370"/>
+                </a:solidFill>
+                <a:latin typeface="Calibri"/>
+              </a:rPr>
+              <a:t>BASE DE DONNÉES</a:t>
+            </a:r>
+          </a:p>
+        </p:txBody>
+      </p:sp>
+      <p:sp>
+        <p:nvSpPr>
+          <p:cNvPr id="17" name="TextBox 16"/>
+          <p:cNvSpPr txBox="1"/>
+          <p:nvPr/>
+        </p:nvSpPr>
+        <p:spPr>
+          <a:xfrm>
+            <a:off x="5285231" y="2148840"/>
+            <a:ext cx="1600200" cy="685800"/>
+          </a:xfrm>
+          <a:prstGeom prst="rect">
+            <a:avLst/>
+          </a:prstGeom>
+          <a:noFill/>
+        </p:spPr>
+        <p:txBody>
+          <a:bodyPr wrap="square" lIns="0" rIns="0" tIns="0" bIns="0" anchor="t">
+            <a:spAutoFit/>
+          </a:bodyPr>
+          <a:lstStyle/>
+          <a:p>
+            <a:pPr algn="l"/>
+            <a:r>
+              <a:rPr sz="2600" b="1" i="0">
+                <a:solidFill>
+                  <a:srgbClr val="2A78D6"/>
+                </a:solidFill>
+                <a:latin typeface="Calibri"/>
+              </a:rPr>
+              <a:t>6 tables</a:t>
+            </a:r>
+          </a:p>
+        </p:txBody>
+      </p:sp>
+      <p:sp>
+        <p:nvSpPr>
+          <p:cNvPr id="18" name="TextBox 17"/>
+          <p:cNvSpPr txBox="1"/>
+          <p:nvPr/>
+        </p:nvSpPr>
+        <p:spPr>
+          <a:xfrm>
+            <a:off x="5285231" y="2834640"/>
+            <a:ext cx="1600200" cy="1097280"/>
+          </a:xfrm>
+          <a:prstGeom prst="rect">
+            <a:avLst/>
+          </a:prstGeom>
+          <a:noFill/>
+        </p:spPr>
+        <p:txBody>
+          <a:bodyPr wrap="square" lIns="0" rIns="0" tIns="0" bIns="0" anchor="t">
+            <a:spAutoFit/>
+          </a:bodyPr>
+          <a:lstStyle/>
+          <a:p>
+            <a:pPr algn="l"/>
+            <a:r>
+              <a:rPr sz="1400" b="0" i="0">
+                <a:solidFill>
+                  <a:srgbClr val="1F2937"/>
+                </a:solidFill>
+                <a:latin typeface="Calibri"/>
+              </a:rPr>
+              <a:t>reliées : régions, communes, stations, bornes…</a:t>
+            </a:r>
+          </a:p>
+        </p:txBody>
+      </p:sp>
+      <p:sp>
+        <p:nvSpPr>
+          <p:cNvPr id="19" name="Chevron 18"/>
+          <p:cNvSpPr/>
+          <p:nvPr/>
+        </p:nvSpPr>
+        <p:spPr>
+          <a:xfrm>
+            <a:off x="7123175" y="2606040"/>
+            <a:ext cx="201168" cy="310896"/>
+          </a:xfrm>
+          <a:prstGeom prst="chevron">
+            <a:avLst/>
+          </a:prstGeom>
+          <a:solidFill>
+            <a:srgbClr val="5B6370"/>
+          </a:solidFill>
+          <a:ln>
+            <a:noFill/>
+          </a:ln>
+          <a:effectLst/>
+        </p:spPr>
+        <p:style>
+          <a:lnRef idx="1">
+            <a:schemeClr val="accent1"/>
+          </a:lnRef>
+          <a:fillRef idx="3">
+            <a:schemeClr val="accent1"/>
+          </a:fillRef>
+          <a:effectRef idx="2">
+            <a:schemeClr val="accent1"/>
+          </a:effectRef>
+          <a:fontRef idx="minor">
+            <a:schemeClr val="lt1"/>
+          </a:fontRef>
+        </p:style>
+        <p:txBody>
+          <a:bodyPr rtlCol="0" anchor="ctr"/>
+          <a:lstStyle/>
+          <a:p>
+            <a:pPr algn="ctr"/>
+          </a:p>
+        </p:txBody>
+      </p:sp>
+      <p:sp>
+        <p:nvSpPr>
+          <p:cNvPr id="20" name="Rounded Rectangle 19"/>
+          <p:cNvSpPr/>
+          <p:nvPr/>
+        </p:nvSpPr>
+        <p:spPr>
+          <a:xfrm>
+            <a:off x="7379207" y="1554480"/>
+            <a:ext cx="1965960" cy="2423160"/>
+          </a:xfrm>
+          <a:prstGeom prst="roundRect">
+            <a:avLst>
+              <a:gd name="adj" fmla="val 8000"/>
+            </a:avLst>
+          </a:prstGeom>
+          <a:solidFill>
+            <a:srgbClr val="F1F4F8"/>
+          </a:solidFill>
+          <a:ln>
+            <a:noFill/>
+          </a:ln>
+          <a:effectLst/>
+        </p:spPr>
+        <p:style>
+          <a:lnRef idx="1">
+            <a:schemeClr val="accent1"/>
+          </a:lnRef>
+          <a:fillRef idx="3">
+            <a:schemeClr val="accent1"/>
+          </a:fillRef>
+          <a:effectRef idx="2">
+            <a:schemeClr val="accent1"/>
+          </a:effectRef>
+          <a:fontRef idx="minor">
+            <a:schemeClr val="lt1"/>
+          </a:fontRef>
+        </p:style>
+        <p:txBody>
+          <a:bodyPr rtlCol="0" anchor="ctr"/>
+          <a:lstStyle/>
+          <a:p>
+            <a:pPr algn="ctr"/>
+          </a:p>
+        </p:txBody>
+      </p:sp>
+      <p:sp>
+        <p:nvSpPr>
+          <p:cNvPr id="21" name="TextBox 20"/>
+          <p:cNvSpPr txBox="1"/>
+          <p:nvPr/>
+        </p:nvSpPr>
+        <p:spPr>
+          <a:xfrm>
+            <a:off x="7562087" y="1737360"/>
+            <a:ext cx="1600200" cy="411480"/>
+          </a:xfrm>
+          <a:prstGeom prst="rect">
+            <a:avLst/>
+          </a:prstGeom>
+          <a:noFill/>
+        </p:spPr>
+        <p:txBody>
+          <a:bodyPr wrap="square" lIns="0" rIns="0" tIns="0" bIns="0" anchor="t">
+            <a:spAutoFit/>
+          </a:bodyPr>
+          <a:lstStyle/>
+          <a:p>
+            <a:pPr algn="l"/>
+            <a:r>
+              <a:rPr sz="1200" b="1" i="0">
+                <a:solidFill>
+                  <a:srgbClr val="5B6370"/>
+                </a:solidFill>
+                <a:latin typeface="Calibri"/>
+              </a:rPr>
+              <a:t>API</a:t>
+            </a:r>
+          </a:p>
+        </p:txBody>
+      </p:sp>
+      <p:sp>
+        <p:nvSpPr>
+          <p:cNvPr id="22" name="TextBox 21"/>
+          <p:cNvSpPr txBox="1"/>
+          <p:nvPr/>
+        </p:nvSpPr>
+        <p:spPr>
+          <a:xfrm>
+            <a:off x="7562087" y="2148840"/>
+            <a:ext cx="1600200" cy="685800"/>
+          </a:xfrm>
+          <a:prstGeom prst="rect">
+            <a:avLst/>
+          </a:prstGeom>
+          <a:noFill/>
+        </p:spPr>
+        <p:txBody>
+          <a:bodyPr wrap="square" lIns="0" rIns="0" tIns="0" bIns="0" anchor="t">
+            <a:spAutoFit/>
+          </a:bodyPr>
+          <a:lstStyle/>
+          <a:p>
+            <a:pPr algn="l"/>
+            <a:r>
+              <a:rPr sz="2600" b="1" i="0">
+                <a:solidFill>
+                  <a:srgbClr val="EB6834"/>
+                </a:solidFill>
+                <a:latin typeface="Calibri"/>
+              </a:rPr>
+              <a:t>Un guichet</a:t>
+            </a:r>
+          </a:p>
+        </p:txBody>
+      </p:sp>
+      <p:sp>
+        <p:nvSpPr>
+          <p:cNvPr id="23" name="TextBox 22"/>
+          <p:cNvSpPr txBox="1"/>
+          <p:nvPr/>
+        </p:nvSpPr>
+        <p:spPr>
+          <a:xfrm>
+            <a:off x="7562087" y="2834640"/>
+            <a:ext cx="1600200" cy="1097280"/>
+          </a:xfrm>
+          <a:prstGeom prst="rect">
+            <a:avLst/>
+          </a:prstGeom>
+          <a:noFill/>
+        </p:spPr>
+        <p:txBody>
+          <a:bodyPr wrap="square" lIns="0" rIns="0" tIns="0" bIns="0" anchor="t">
+            <a:spAutoFit/>
+          </a:bodyPr>
+          <a:lstStyle/>
+          <a:p>
+            <a:pPr algn="l"/>
+            <a:r>
+              <a:rPr sz="1400" b="0" i="0">
+                <a:solidFill>
+                  <a:srgbClr val="1F2937"/>
+                </a:solidFill>
+                <a:latin typeface="Calibri"/>
+              </a:rPr>
+              <a:t>consulter : ouvert à tous ; modifier : réservé, avec une clé</a:t>
+            </a:r>
+          </a:p>
+        </p:txBody>
+      </p:sp>
+      <p:sp>
+        <p:nvSpPr>
+          <p:cNvPr id="24" name="Chevron 23"/>
+          <p:cNvSpPr/>
+          <p:nvPr/>
+        </p:nvSpPr>
+        <p:spPr>
+          <a:xfrm>
+            <a:off x="9400032" y="2606040"/>
+            <a:ext cx="201168" cy="310896"/>
+          </a:xfrm>
+          <a:prstGeom prst="chevron">
+            <a:avLst/>
+          </a:prstGeom>
+          <a:solidFill>
+            <a:srgbClr val="5B6370"/>
+          </a:solidFill>
+          <a:ln>
+            <a:noFill/>
+          </a:ln>
+          <a:effectLst/>
+        </p:spPr>
+        <p:style>
+          <a:lnRef idx="1">
+            <a:schemeClr val="accent1"/>
+          </a:lnRef>
+          <a:fillRef idx="3">
+            <a:schemeClr val="accent1"/>
+          </a:fillRef>
+          <a:effectRef idx="2">
+            <a:schemeClr val="accent1"/>
+          </a:effectRef>
+          <a:fontRef idx="minor">
+            <a:schemeClr val="lt1"/>
+          </a:fontRef>
+        </p:style>
+        <p:txBody>
+          <a:bodyPr rtlCol="0" anchor="ctr"/>
+          <a:lstStyle/>
+          <a:p>
+            <a:pPr algn="ctr"/>
+          </a:p>
+        </p:txBody>
+      </p:sp>
+      <p:sp>
+        <p:nvSpPr>
+          <p:cNvPr id="25" name="Rounded Rectangle 24"/>
+          <p:cNvSpPr/>
+          <p:nvPr/>
+        </p:nvSpPr>
+        <p:spPr>
+          <a:xfrm>
+            <a:off x="9656063" y="1554480"/>
+            <a:ext cx="1965960" cy="2423160"/>
+          </a:xfrm>
+          <a:prstGeom prst="roundRect">
+            <a:avLst>
+              <a:gd name="adj" fmla="val 8000"/>
+            </a:avLst>
+          </a:prstGeom>
+          <a:solidFill>
+            <a:srgbClr val="F1F4F8"/>
+          </a:solidFill>
+          <a:ln>
+            <a:noFill/>
+          </a:ln>
+          <a:effectLst/>
+        </p:spPr>
+        <p:style>
+          <a:lnRef idx="1">
+            <a:schemeClr val="accent1"/>
+          </a:lnRef>
+          <a:fillRef idx="3">
+            <a:schemeClr val="accent1"/>
+          </a:fillRef>
+          <a:effectRef idx="2">
+            <a:schemeClr val="accent1"/>
+          </a:effectRef>
+          <a:fontRef idx="minor">
+            <a:schemeClr val="lt1"/>
+          </a:fontRef>
+        </p:style>
+        <p:txBody>
+          <a:bodyPr rtlCol="0" anchor="ctr"/>
+          <a:lstStyle/>
+          <a:p>
+            <a:pPr algn="ctr"/>
+          </a:p>
+        </p:txBody>
+      </p:sp>
+      <p:sp>
+        <p:nvSpPr>
+          <p:cNvPr id="26" name="TextBox 25"/>
+          <p:cNvSpPr txBox="1"/>
+          <p:nvPr/>
+        </p:nvSpPr>
+        <p:spPr>
+          <a:xfrm>
+            <a:off x="9838943" y="1737360"/>
+            <a:ext cx="1600200" cy="411480"/>
+          </a:xfrm>
+          <a:prstGeom prst="rect">
+            <a:avLst/>
+          </a:prstGeom>
+          <a:noFill/>
+        </p:spPr>
+        <p:txBody>
+          <a:bodyPr wrap="square" lIns="0" rIns="0" tIns="0" bIns="0" anchor="t">
+            <a:spAutoFit/>
+          </a:bodyPr>
+          <a:lstStyle/>
+          <a:p>
+            <a:pPr algn="l"/>
+            <a:r>
+              <a:rPr sz="1200" b="1" i="0">
+                <a:solidFill>
+                  <a:srgbClr val="5B6370"/>
+                </a:solidFill>
+                <a:latin typeface="Calibri"/>
+              </a:rPr>
+              <a:t>RÉSULTATS</a:t>
+            </a:r>
+          </a:p>
+        </p:txBody>
+      </p:sp>
+      <p:sp>
+        <p:nvSpPr>
+          <p:cNvPr id="27" name="TextBox 26"/>
+          <p:cNvSpPr txBox="1"/>
+          <p:nvPr/>
+        </p:nvSpPr>
+        <p:spPr>
+          <a:xfrm>
+            <a:off x="9838943" y="2148840"/>
+            <a:ext cx="1600200" cy="685800"/>
+          </a:xfrm>
+          <a:prstGeom prst="rect">
+            <a:avLst/>
+          </a:prstGeom>
+          <a:noFill/>
+        </p:spPr>
+        <p:txBody>
+          <a:bodyPr wrap="square" lIns="0" rIns="0" tIns="0" bIns="0" anchor="t">
+            <a:spAutoFit/>
+          </a:bodyPr>
+          <a:lstStyle/>
+          <a:p>
+            <a:pPr algn="l"/>
+            <a:r>
+              <a:rPr sz="2600" b="1" i="0">
+                <a:solidFill>
+                  <a:srgbClr val="E34948"/>
+                </a:solidFill>
+                <a:latin typeface="Calibri"/>
+              </a:rPr>
+              <a:t>3 usages</a:t>
+            </a:r>
+          </a:p>
+        </p:txBody>
+      </p:sp>
+      <p:sp>
+        <p:nvSpPr>
+          <p:cNvPr id="28" name="TextBox 27"/>
+          <p:cNvSpPr txBox="1"/>
+          <p:nvPr/>
+        </p:nvSpPr>
+        <p:spPr>
+          <a:xfrm>
+            <a:off x="9838943" y="2834640"/>
+            <a:ext cx="1600200" cy="1097280"/>
+          </a:xfrm>
+          <a:prstGeom prst="rect">
+            <a:avLst/>
+          </a:prstGeom>
+          <a:noFill/>
+        </p:spPr>
+        <p:txBody>
+          <a:bodyPr wrap="square" lIns="0" rIns="0" tIns="0" bIns="0" anchor="t">
+            <a:spAutoFit/>
+          </a:bodyPr>
+          <a:lstStyle/>
+          <a:p>
+            <a:pPr algn="l"/>
+            <a:r>
+              <a:rPr sz="1400" b="0" i="0">
+                <a:solidFill>
+                  <a:srgbClr val="1F2937"/>
+                </a:solidFill>
+                <a:latin typeface="Calibri"/>
+              </a:rPr>
+              <a:t>tableau de bord, modèle de prédiction, typologie des stations</a:t>
+            </a:r>
+          </a:p>
+        </p:txBody>
+      </p:sp>
+      <p:sp>
+        <p:nvSpPr>
+          <p:cNvPr id="29" name="Rounded Rectangle 28"/>
+          <p:cNvSpPr/>
+          <p:nvPr/>
+        </p:nvSpPr>
+        <p:spPr>
+          <a:xfrm>
+            <a:off x="548640" y="4206240"/>
+            <a:ext cx="11109960" cy="2011680"/>
+          </a:xfrm>
+          <a:prstGeom prst="roundRect">
+            <a:avLst>
+              <a:gd name="adj" fmla="val 8000"/>
+            </a:avLst>
+          </a:prstGeom>
+          <a:solidFill>
+            <a:srgbClr val="14213D"/>
+          </a:solidFill>
+          <a:ln>
+            <a:noFill/>
+          </a:ln>
+          <a:effectLst/>
+        </p:spPr>
+        <p:style>
+          <a:lnRef idx="1">
+            <a:schemeClr val="accent1"/>
+          </a:lnRef>
+          <a:fillRef idx="3">
+            <a:schemeClr val="accent1"/>
+          </a:fillRef>
+          <a:effectRef idx="2">
+            <a:schemeClr val="accent1"/>
+          </a:effectRef>
+          <a:fontRef idx="minor">
+            <a:schemeClr val="lt1"/>
+          </a:fontRef>
+        </p:style>
+        <p:txBody>
+          <a:bodyPr rtlCol="0" anchor="ctr"/>
+          <a:lstStyle/>
+          <a:p>
+            <a:pPr algn="ctr"/>
+          </a:p>
+        </p:txBody>
+      </p:sp>
+      <p:sp>
+        <p:nvSpPr>
+          <p:cNvPr id="30" name="TextBox 29"/>
+          <p:cNvSpPr txBox="1"/>
+          <p:nvPr/>
+        </p:nvSpPr>
+        <p:spPr>
+          <a:xfrm>
+            <a:off x="868680" y="4389120"/>
+            <a:ext cx="5120640" cy="365760"/>
+          </a:xfrm>
+          <a:prstGeom prst="rect">
+            <a:avLst/>
+          </a:prstGeom>
+          <a:noFill/>
+        </p:spPr>
+        <p:txBody>
+          <a:bodyPr wrap="square" lIns="0" rIns="0" tIns="0" bIns="0" anchor="t">
+            <a:spAutoFit/>
+          </a:bodyPr>
+          <a:lstStyle/>
+          <a:p>
+            <a:pPr algn="l"/>
+            <a:r>
+              <a:rPr sz="1600" b="1" i="0">
+                <a:solidFill>
+                  <a:srgbClr val="CADCFC"/>
+                </a:solidFill>
+                <a:latin typeface="Calibri"/>
+              </a:rPr>
+              <a:t>Consulter : ouvert à tous, sans clé</a:t>
+            </a:r>
+          </a:p>
+        </p:txBody>
+      </p:sp>
+      <p:sp>
+        <p:nvSpPr>
+          <p:cNvPr id="31" name="TextBox 30"/>
+          <p:cNvSpPr txBox="1"/>
+          <p:nvPr/>
+        </p:nvSpPr>
+        <p:spPr>
+          <a:xfrm>
+            <a:off x="868680" y="4800600"/>
+            <a:ext cx="5120640" cy="1371600"/>
+          </a:xfrm>
+          <a:prstGeom prst="rect">
+            <a:avLst/>
+          </a:prstGeom>
+          <a:noFill/>
+        </p:spPr>
+        <p:txBody>
+          <a:bodyPr wrap="square" lIns="0" rIns="0" tIns="0" bIns="0" anchor="t">
+            <a:spAutoFit/>
+          </a:bodyPr>
+          <a:lstStyle/>
+          <a:p>
+            <a:pPr algn="l">
+              <a:spcAft>
+                <a:spcPts val="800"/>
+              </a:spcAft>
+            </a:pPr>
+            <a:r>
+              <a:rPr sz="1500" b="0" i="0">
+                <a:solidFill>
+                  <a:srgbClr val="FFFFFF"/>
+                </a:solidFill>
+                <a:latin typeface="Calibri"/>
+              </a:rPr>
+              <a:t>Chiffres clés et déserts</a:t>
+            </a:r>
+          </a:p>
+          <a:p>
+            <a:pPr algn="l">
+              <a:spcAft>
+                <a:spcPts val="800"/>
+              </a:spcAft>
+            </a:pPr>
+            <a:r>
+              <a:rPr sz="1200" b="0" i="0">
+                <a:solidFill>
+                  <a:srgbClr val="CADCFC"/>
+                </a:solidFill>
+                <a:latin typeface="Calibri"/>
+              </a:rPr>
+              <a:t>GET /stats, /deserts</a:t>
+            </a:r>
+          </a:p>
+          <a:p>
+            <a:pPr algn="l">
+              <a:spcAft>
+                <a:spcPts val="800"/>
+              </a:spcAft>
+            </a:pPr>
+            <a:r>
+              <a:rPr sz="1500" b="0" i="0">
+                <a:solidFill>
+                  <a:srgbClr val="FFFFFF"/>
+                </a:solidFill>
+                <a:latin typeface="Calibri"/>
+              </a:rPr>
+              <a:t>Communes, stations, bornes</a:t>
+            </a:r>
+          </a:p>
+          <a:p>
+            <a:pPr algn="l"/>
+            <a:r>
+              <a:rPr sz="1200" b="0" i="0">
+                <a:solidFill>
+                  <a:srgbClr val="CADCFC"/>
+                </a:solidFill>
+                <a:latin typeface="Calibri"/>
+              </a:rPr>
+              <a:t>GET /communes, /stations, /points‑de‑charge</a:t>
+            </a:r>
+          </a:p>
+        </p:txBody>
+      </p:sp>
+      <p:sp>
+        <p:nvSpPr>
+          <p:cNvPr id="32" name="TextBox 31"/>
+          <p:cNvSpPr txBox="1"/>
+          <p:nvPr/>
+        </p:nvSpPr>
+        <p:spPr>
+          <a:xfrm>
+            <a:off x="6400800" y="4389120"/>
+            <a:ext cx="5120640" cy="365760"/>
+          </a:xfrm>
+          <a:prstGeom prst="rect">
+            <a:avLst/>
+          </a:prstGeom>
+          <a:noFill/>
+        </p:spPr>
+        <p:txBody>
+          <a:bodyPr wrap="square" lIns="0" rIns="0" tIns="0" bIns="0" anchor="t">
+            <a:spAutoFit/>
+          </a:bodyPr>
+          <a:lstStyle/>
+          <a:p>
+            <a:pPr algn="l"/>
+            <a:r>
+              <a:rPr sz="1600" b="1" i="0">
+                <a:solidFill>
+                  <a:srgbClr val="F6B89E"/>
+                </a:solidFill>
+                <a:latin typeface="Calibri"/>
+              </a:rPr>
+              <a:t>Modifier : réservé, avec une clé</a:t>
+            </a:r>
+          </a:p>
+        </p:txBody>
+      </p:sp>
+      <p:sp>
+        <p:nvSpPr>
+          <p:cNvPr id="33" name="TextBox 32"/>
+          <p:cNvSpPr txBox="1"/>
+          <p:nvPr/>
+        </p:nvSpPr>
+        <p:spPr>
+          <a:xfrm>
+            <a:off x="6400800" y="4800600"/>
+            <a:ext cx="5120640" cy="1371600"/>
+          </a:xfrm>
+          <a:prstGeom prst="rect">
+            <a:avLst/>
+          </a:prstGeom>
+          <a:noFill/>
+        </p:spPr>
+        <p:txBody>
+          <a:bodyPr wrap="square" lIns="0" rIns="0" tIns="0" bIns="0" anchor="t">
+            <a:spAutoFit/>
+          </a:bodyPr>
+          <a:lstStyle/>
+          <a:p>
+            <a:pPr algn="l">
+              <a:spcAft>
+                <a:spcPts val="800"/>
+              </a:spcAft>
+            </a:pPr>
+            <a:r>
+              <a:rPr sz="1500" b="0" i="0">
+                <a:solidFill>
+                  <a:srgbClr val="FFFFFF"/>
+                </a:solidFill>
+                <a:latin typeface="Calibri"/>
+              </a:rPr>
+              <a:t>Ajouter, remplacer ou corriger une borne</a:t>
+            </a:r>
+          </a:p>
+          <a:p>
+            <a:pPr algn="l">
+              <a:spcAft>
+                <a:spcPts val="800"/>
+              </a:spcAft>
+            </a:pPr>
+            <a:r>
+              <a:rPr sz="1200" b="0" i="0">
+                <a:solidFill>
+                  <a:srgbClr val="CADCFC"/>
+                </a:solidFill>
+                <a:latin typeface="Calibri"/>
+              </a:rPr>
+              <a:t>POST, PUT, PATCH /points‑de‑charge</a:t>
+            </a:r>
+          </a:p>
+          <a:p>
+            <a:pPr algn="l">
+              <a:spcAft>
+                <a:spcPts val="800"/>
+              </a:spcAft>
+            </a:pPr>
+            <a:r>
+              <a:rPr sz="1500" b="0" i="0">
+                <a:solidFill>
+                  <a:srgbClr val="FFFFFF"/>
+                </a:solidFill>
+                <a:latin typeface="Calibri"/>
+              </a:rPr>
+              <a:t>Supprimer une borne</a:t>
+            </a:r>
+          </a:p>
+          <a:p>
+            <a:pPr algn="l"/>
+            <a:r>
+              <a:rPr sz="1200" b="0" i="0">
+                <a:solidFill>
+                  <a:srgbClr val="CADCFC"/>
+                </a:solidFill>
+                <a:latin typeface="Calibri"/>
+              </a:rPr>
+              <a:t>DELETE /points‑de‑charge</a:t>
+            </a:r>
+          </a:p>
+        </p:txBody>
+      </p:sp>
+    </p:spTree>
+  </p:cSld>
+  <p:clrMapOvr>
+    <a:masterClrMapping/>
+  </p:clrMapOvr>
+</p:sld>
+</file>
+
+<file path=ppt/slides/slide11.xml><?xml version="1.0" encoding="utf-8"?>
+<p:sld xmlns:a="http://schemas.openxmlformats.org/drawingml/2006/main" xmlns:p="http://schemas.openxmlformats.org/presentationml/2006/main" xmlns:r="http://schemas.openxmlformats.org/officeDocument/2006/relationships">
+  <p:cSld>
+    <p:bg>
+      <p:bgPr>
+        <a:solidFill>
           <a:srgbClr val="14213D"/>
         </a:solidFill>
         <a:effectLst/>
@@ -5206,7 +6621,7 @@
                 </a:solidFill>
                 <a:latin typeface="Calibri"/>
               </a:rPr>
-              <a:t>10</a:t>
+              <a:t>11</a:t>
             </a:r>
           </a:p>
         </p:txBody>
@@ -8723,8 +10138,8 @@
         </p:nvSpPr>
         <p:spPr>
           <a:xfrm>
-            <a:off x="548640" y="1371600"/>
-            <a:ext cx="5852160" cy="365760"/>
+            <a:off x="548640" y="1280160"/>
+            <a:ext cx="11064240" cy="411480"/>
           </a:xfrm>
           <a:prstGeom prst="rect">
             <a:avLst/>
@@ -8739,6 +10154,41 @@
           <a:p>
             <a:pPr algn="l"/>
             <a:r>
+              <a:rPr sz="1800" b="1" i="0">
+                <a:solidFill>
+                  <a:srgbClr val="14213D"/>
+                </a:solidFill>
+                <a:latin typeface="Calibri"/>
+              </a:rPr>
+              <a:t>La question posée au modèle : au vu de son profil, cette commune devrait-elle avoir une borne ?</a:t>
+            </a:r>
+          </a:p>
+        </p:txBody>
+      </p:sp>
+      <p:sp>
+        <p:nvSpPr>
+          <p:cNvPr id="6" name="TextBox 5"/>
+          <p:cNvSpPr txBox="1"/>
+          <p:nvPr/>
+        </p:nvSpPr>
+        <p:spPr>
+          <a:xfrm>
+            <a:off x="548640" y="1828800"/>
+            <a:ext cx="5852160" cy="365760"/>
+          </a:xfrm>
+          <a:prstGeom prst="rect">
+            <a:avLst/>
+          </a:prstGeom>
+          <a:noFill/>
+        </p:spPr>
+        <p:txBody>
+          <a:bodyPr wrap="square" lIns="0" rIns="0" tIns="0" bIns="0" anchor="t">
+            <a:spAutoFit/>
+          </a:bodyPr>
+          <a:lstStyle/>
+          <a:p>
+            <a:pPr algn="l"/>
+            <a:r>
               <a:rPr sz="1500" b="0" i="0">
                 <a:solidFill>
                   <a:srgbClr val="5B6370"/>
@@ -8752,15 +10202,15 @@
       </p:sp>
       <p:graphicFrame>
         <p:nvGraphicFramePr>
-          <p:cNvPr id="6" name="Chart 5"/>
+          <p:cNvPr id="7" name="Chart 6"/>
           <p:cNvGraphicFramePr>
             <a:graphicFrameLocks noGrp="1"/>
           </p:cNvGraphicFramePr>
           <p:nvPr/>
         </p:nvGraphicFramePr>
         <p:xfrm>
-          <a:off x="457200" y="1737360"/>
-          <a:ext cx="5943600" cy="4480560"/>
+          <a:off x="457200" y="2194560"/>
+          <a:ext cx="5943600" cy="4023360"/>
         </p:xfrm>
         <a:graphic>
           <a:graphicData uri="http://schemas.openxmlformats.org/drawingml/2006/chart">
@@ -8770,14 +10220,14 @@
       </p:graphicFrame>
       <p:sp>
         <p:nvSpPr>
-          <p:cNvPr id="7" name="Rounded Rectangle 6"/>
+          <p:cNvPr id="8" name="Rounded Rectangle 7"/>
           <p:cNvSpPr/>
           <p:nvPr/>
         </p:nvSpPr>
         <p:spPr>
           <a:xfrm>
-            <a:off x="6675120" y="1508760"/>
-            <a:ext cx="2377440" cy="1828800"/>
+            <a:off x="6675120" y="1874519"/>
+            <a:ext cx="2377440" cy="1645920"/>
           </a:xfrm>
           <a:prstGeom prst="roundRect">
             <a:avLst>
@@ -8816,14 +10266,14 @@
       </p:sp>
       <p:sp>
         <p:nvSpPr>
-          <p:cNvPr id="8" name="TextBox 7"/>
+          <p:cNvPr id="9" name="TextBox 8"/>
           <p:cNvSpPr txBox="1"/>
           <p:nvPr/>
         </p:nvSpPr>
         <p:spPr>
           <a:xfrm>
-            <a:off x="6949440" y="1737360"/>
-            <a:ext cx="1828800" cy="914400"/>
+            <a:off x="6949440" y="2103120"/>
+            <a:ext cx="1828800" cy="822960"/>
           </a:xfrm>
           <a:prstGeom prst="rect">
             <a:avLst/>
@@ -8851,14 +10301,14 @@
       </p:sp>
       <p:sp>
         <p:nvSpPr>
-          <p:cNvPr id="9" name="TextBox 8"/>
+          <p:cNvPr id="10" name="TextBox 9"/>
           <p:cNvSpPr txBox="1"/>
           <p:nvPr/>
         </p:nvSpPr>
         <p:spPr>
           <a:xfrm>
-            <a:off x="6949440" y="2697480"/>
-            <a:ext cx="1828800" cy="457200"/>
+            <a:off x="6949440" y="2971799"/>
+            <a:ext cx="1828800" cy="374904"/>
           </a:xfrm>
           <a:prstGeom prst="rect">
             <a:avLst/>
@@ -8886,14 +10336,14 @@
       </p:sp>
       <p:sp>
         <p:nvSpPr>
-          <p:cNvPr id="10" name="Rounded Rectangle 9"/>
+          <p:cNvPr id="11" name="Rounded Rectangle 10"/>
           <p:cNvSpPr/>
           <p:nvPr/>
         </p:nvSpPr>
         <p:spPr>
           <a:xfrm>
-            <a:off x="9281160" y="1508760"/>
-            <a:ext cx="2377440" cy="1828800"/>
+            <a:off x="9281160" y="1874519"/>
+            <a:ext cx="2377440" cy="1645920"/>
           </a:xfrm>
           <a:prstGeom prst="roundRect">
             <a:avLst>
@@ -8932,14 +10382,14 @@
       </p:sp>
       <p:sp>
         <p:nvSpPr>
-          <p:cNvPr id="11" name="TextBox 10"/>
+          <p:cNvPr id="12" name="TextBox 11"/>
           <p:cNvSpPr txBox="1"/>
           <p:nvPr/>
         </p:nvSpPr>
         <p:spPr>
           <a:xfrm>
-            <a:off x="9555480" y="1737360"/>
-            <a:ext cx="1828800" cy="914400"/>
+            <a:off x="9555480" y="2103120"/>
+            <a:ext cx="1828800" cy="822960"/>
           </a:xfrm>
           <a:prstGeom prst="rect">
             <a:avLst/>
@@ -8967,14 +10417,14 @@
       </p:sp>
       <p:sp>
         <p:nvSpPr>
-          <p:cNvPr id="12" name="TextBox 11"/>
+          <p:cNvPr id="13" name="TextBox 12"/>
           <p:cNvSpPr txBox="1"/>
           <p:nvPr/>
         </p:nvSpPr>
         <p:spPr>
           <a:xfrm>
-            <a:off x="9555480" y="2697480"/>
-            <a:ext cx="1828800" cy="457200"/>
+            <a:off x="9555480" y="2971799"/>
+            <a:ext cx="1828800" cy="374904"/>
           </a:xfrm>
           <a:prstGeom prst="rect">
             <a:avLst/>
@@ -9002,14 +10452,14 @@
       </p:sp>
       <p:sp>
         <p:nvSpPr>
-          <p:cNvPr id="13" name="Rounded Rectangle 12"/>
+          <p:cNvPr id="14" name="Rounded Rectangle 13"/>
           <p:cNvSpPr/>
           <p:nvPr/>
         </p:nvSpPr>
         <p:spPr>
           <a:xfrm>
-            <a:off x="6675120" y="3566160"/>
-            <a:ext cx="4983480" cy="2606040"/>
+            <a:off x="6675120" y="3703320"/>
+            <a:ext cx="4983480" cy="2514600"/>
           </a:xfrm>
           <a:prstGeom prst="roundRect">
             <a:avLst>
@@ -9048,13 +10498,13 @@
       </p:sp>
       <p:sp>
         <p:nvSpPr>
-          <p:cNvPr id="14" name="TextBox 13"/>
+          <p:cNvPr id="15" name="TextBox 14"/>
           <p:cNvSpPr txBox="1"/>
           <p:nvPr/>
         </p:nvSpPr>
         <p:spPr>
           <a:xfrm>
-            <a:off x="6949440" y="3794760"/>
+            <a:off x="6949440" y="3886200"/>
             <a:ext cx="4480560" cy="2194560"/>
           </a:xfrm>
           <a:prstGeom prst="rect">
@@ -9118,24 +10568,49 @@
             </a:r>
           </a:p>
           <a:p>
+            <a:pPr algn="l">
+              <a:spcAft>
+                <a:spcPts val="800"/>
+              </a:spcAft>
+            </a:pPr>
+            <a:r>
+              <a:rPr sz="1600" b="1" i="0">
+                <a:solidFill>
+                  <a:srgbClr val="1F2937"/>
+                </a:solidFill>
+                <a:latin typeface="Calibri"/>
+              </a:rPr>
+              <a:t>Ex. : </a:t>
+            </a:r>
+            <a:r>
+              <a:rPr sz="1600" b="0" i="0">
+                <a:solidFill>
+                  <a:srgbClr val="1F2937"/>
+                </a:solidFill>
+                <a:latin typeface="Calibri"/>
+              </a:rPr>
+              <a:t>Thorigny-sur-Marne, 10 440 habitants, borne la plus proche à 1,3 km</a:t>
+            </a:r>
+          </a:p>
+          <a:p>
             <a:pPr algn="l"/>
             <a:r>
               <a:rPr sz="1600" b="1" i="0">
                 <a:solidFill>
-                  <a:srgbClr val="1F2937"/>
-                </a:solidFill>
-                <a:latin typeface="Calibri"/>
-              </a:rPr>
-              <a:t>Ex. : </a:t>
-            </a:r>
-            <a:r>
-              <a:rPr sz="1600" b="0" i="0">
-                <a:solidFill>
-                  <a:srgbClr val="1F2937"/>
-                </a:solidFill>
-                <a:latin typeface="Calibri"/>
-              </a:rPr>
-              <a:t>Thorigny-sur-Marne, 10 440 habitants, borne la plus proche à 1,3 km</a:t>
+                  <a:srgbClr val="14213D"/>
+                </a:solidFill>
+                <a:latin typeface="Calibri"/>
+              </a:rPr>
+              <a:t>Machine learning : </a:t>
+            </a:r>
+            <a:r>
+              <a:rPr sz="1400" b="0" i="0">
+                <a:solidFill>
+                  <a:srgbClr val="5B6370"/>
+                </a:solidFill>
+                <a:latin typeface="Calibri"/>
+              </a:rPr>
+              <a:t>3 modèles comparés, le plus simple retenu ; juste dans 87 % des comparaisons, testé sur 20 départements jamais vus</a:t>
             </a:r>
           </a:p>
         </p:txBody>

</xml_diff>

<commit_message>
Restitution : diapositive de comparaison des trois modèles
- Nouvelle diapositive 11 : scores (AUC) de la Logistic Regression, de la
  Random Forest, de XGBoost et de la baseline, et raisons du choix du
  modèle le plus simple
- Réponses : semaine 7 (12 diapositives) ; semaine 6, durées
  d'entraînement formulées sans valeur fixe

Co-Authored-By: Claude Opus 5.5 <noreply@anthropic.com>
</commit_message>
<xml_diff>
--- a/docs/restitution_irve.pptx
+++ b/docs/restitution_irve.pptx
@@ -16,6 +16,7 @@
     <p:sldId id="264" r:id="rId16"/>
     <p:sldId id="265" r:id="rId17"/>
     <p:sldId id="266" r:id="rId18"/>
+    <p:sldId id="267" r:id="rId19"/>
   </p:sldIdLst>
   <p:sldSz cx="12191695" cy="6858000" type="screen4x3"/>
   <p:notesSz cx="6858000" cy="9144000"/>
@@ -690,6 +691,188 @@
 </c:chartSpace>
 </file>
 
+<file path=ppt/charts/chart4.xml><?xml version="1.0" encoding="utf-8"?>
+<c:chartSpace xmlns:c="http://schemas.openxmlformats.org/drawingml/2006/chart" xmlns:a="http://schemas.openxmlformats.org/drawingml/2006/main" xmlns:r="http://schemas.openxmlformats.org/officeDocument/2006/relationships">
+  <c:date1904 val="0"/>
+  <c:chart>
+    <c:autoTitleDeleted val="1"/>
+    <c:plotArea>
+      <c:barChart>
+        <c:barDir val="bar"/>
+        <c:grouping val="clustered"/>
+        <c:ser>
+          <c:idx val="0"/>
+          <c:order val="0"/>
+          <c:tx>
+            <c:strRef>
+              <c:f>Sheet1!$B$1</c:f>
+              <c:strCache>
+                <c:ptCount val="1"/>
+                <c:pt idx="0">
+                  <c:v>Série</c:v>
+                </c:pt>
+              </c:strCache>
+            </c:strRef>
+          </c:tx>
+          <c:spPr>
+            <a:solidFill>
+              <a:srgbClr val="2A78D6"/>
+            </a:solidFill>
+          </c:spPr>
+          <c:dPt>
+            <c:idx val="3"/>
+            <c:spPr>
+              <a:solidFill>
+                <a:srgbClr val="5B6370"/>
+              </a:solidFill>
+            </c:spPr>
+          </c:dPt>
+          <c:cat>
+            <c:strRef>
+              <c:f>Sheet1!$A$2:$A$5</c:f>
+              <c:strCache>
+                <c:ptCount val="4"/>
+                <c:pt idx="0">
+                  <c:v>Logistic Regression (retenu)</c:v>
+                </c:pt>
+                <c:pt idx="1">
+                  <c:v>Random Forest</c:v>
+                </c:pt>
+                <c:pt idx="2">
+                  <c:v>XGBoost</c:v>
+                </c:pt>
+                <c:pt idx="3">
+                  <c:v>Taille de la commune seule</c:v>
+                </c:pt>
+              </c:strCache>
+            </c:strRef>
+          </c:cat>
+          <c:val>
+            <c:numRef>
+              <c:f>Sheet1!$B$2:$B$5</c:f>
+              <c:numCache>
+                <c:formatCode>General</c:formatCode>
+                <c:ptCount val="4"/>
+                <c:pt idx="0">
+                  <c:v>0.871</c:v>
+                </c:pt>
+                <c:pt idx="1">
+                  <c:v>0.873</c:v>
+                </c:pt>
+                <c:pt idx="2">
+                  <c:v>0.874</c:v>
+                </c:pt>
+                <c:pt idx="3">
+                  <c:v>0.867</c:v>
+                </c:pt>
+              </c:numCache>
+            </c:numRef>
+          </c:val>
+        </c:ser>
+        <c:dLbls>
+          <c:numFmt formatCode="0.000" sourceLinked="0"/>
+          <c:txPr>
+            <a:bodyPr/>
+            <a:lstStyle/>
+            <a:p>
+              <a:pPr>
+                <a:defRPr sz="1300">
+                  <a:solidFill>
+                    <a:srgbClr val="1F2937"/>
+                  </a:solidFill>
+                  <a:latin typeface="Calibri"/>
+                </a:defRPr>
+              </a:pPr>
+            </a:p>
+          </c:txPr>
+          <c:dLblPos val="outEnd"/>
+          <c:showLegendKey val="0"/>
+          <c:showVal val="1"/>
+          <c:showCatName val="0"/>
+          <c:showSerName val="0"/>
+          <c:showPercent val="0"/>
+          <c:showBubbleSize val="0"/>
+          <c:showLeaderLines val="1"/>
+        </c:dLbls>
+        <c:gapWidth val="45"/>
+        <c:axId val="-2068027336"/>
+        <c:axId val="-2113994440"/>
+      </c:barChart>
+      <c:catAx>
+        <c:axId val="-2068027336"/>
+        <c:scaling>
+          <c:orientation val="maxMin"/>
+        </c:scaling>
+        <c:delete val="0"/>
+        <c:axPos val="l"/>
+        <c:majorTickMark val="out"/>
+        <c:minorTickMark val="none"/>
+        <c:tickLblPos val="nextTo"/>
+        <c:spPr>
+          <a:ln>
+            <a:solidFill>
+              <a:srgbClr val="C3C2B7"/>
+            </a:solidFill>
+          </a:ln>
+        </c:spPr>
+        <c:txPr>
+          <a:bodyPr/>
+          <a:lstStyle/>
+          <a:p>
+            <a:pPr>
+              <a:defRPr sz="1300">
+                <a:solidFill>
+                  <a:srgbClr val="1F2937"/>
+                </a:solidFill>
+              </a:defRPr>
+            </a:pPr>
+          </a:p>
+        </c:txPr>
+        <c:crossAx val="-2113994440"/>
+        <c:crosses val="autoZero"/>
+        <c:auto val="1"/>
+        <c:lblAlgn val="ctr"/>
+        <c:lblOffset val="100"/>
+        <c:noMultiLvlLbl val="0"/>
+      </c:catAx>
+      <c:valAx>
+        <c:axId val="-2113994440"/>
+        <c:scaling>
+          <c:max val="1.0"/>
+          <c:min val="0.0"/>
+        </c:scaling>
+        <c:delete/>
+        <c:axPos val="b"/>
+        <c:majorTickMark val="out"/>
+        <c:minorTickMark val="none"/>
+        <c:tickLblPos val="nextTo"/>
+        <c:crossAx val="-2068027336"/>
+        <c:crosses val="autoZero"/>
+      </c:valAx>
+    </c:plotArea>
+    <c:dispBlanksAs val="gap"/>
+  </c:chart>
+  <c:txPr>
+    <a:bodyPr/>
+    <a:lstStyle/>
+    <a:p>
+      <a:pPr>
+        <a:defRPr sz="1300">
+          <a:solidFill>
+            <a:srgbClr val="1F2937"/>
+          </a:solidFill>
+          <a:latin typeface="Calibri"/>
+        </a:defRPr>
+      </a:pPr>
+      <a:endParaRPr lang="en-US"/>
+    </a:p>
+  </c:txPr>
+  <c:externalData r:id="rId1">
+    <c:autoUpdate val="0"/>
+  </c:externalData>
+</c:chartSpace>
+</file>
+
 <file path=ppt/notesMasters/notesMaster1.xml><?xml version="1.0" encoding="utf-8"?>
 <p:notesMaster xmlns:a="http://schemas.openxmlformats.org/drawingml/2006/main" xmlns:p="http://schemas.openxmlformats.org/presentationml/2006/main" xmlns:r="http://schemas.openxmlformats.org/officeDocument/2006/relationships">
   <p:cSld>
@@ -1181,6 +1364,76 @@
 </file>
 
 <file path=ppt/notesSlides/notesSlide11.xml><?xml version="1.0" encoding="utf-8"?>
+<p:notes xmlns:a="http://schemas.openxmlformats.org/drawingml/2006/main" xmlns:p="http://schemas.openxmlformats.org/presentationml/2006/main" xmlns:r="http://schemas.openxmlformats.org/officeDocument/2006/relationships">
+  <p:cSld>
+    <p:spTree>
+      <p:nvGrpSpPr>
+        <p:cNvPr id="1" name=""/>
+        <p:cNvGrpSpPr/>
+        <p:nvPr/>
+      </p:nvGrpSpPr>
+      <p:grpSpPr>
+        <a:xfrm>
+          <a:off x="0" y="0"/>
+          <a:ext cx="0" cy="0"/>
+          <a:chOff x="0" y="0"/>
+          <a:chExt cx="0" cy="0"/>
+        </a:xfrm>
+      </p:grpSpPr>
+      <p:sp>
+        <p:nvSpPr>
+          <p:cNvPr id="2" name="Slide Image Placeholder 1"/>
+          <p:cNvSpPr>
+            <a:spLocks noGrp="1"/>
+          </p:cNvSpPr>
+          <p:nvPr>
+            <p:ph type="sldImg" idx="2"/>
+          </p:nvPr>
+        </p:nvSpPr>
+        <p:spPr/>
+      </p:sp>
+      <p:sp>
+        <p:nvSpPr>
+          <p:cNvPr id="3" name="Notes Placeholder 2"/>
+          <p:cNvSpPr>
+            <a:spLocks noGrp="1"/>
+          </p:cNvSpPr>
+          <p:nvPr>
+            <p:ph type="body" idx="3" sz="quarter"/>
+          </p:nvPr>
+        </p:nvSpPr>
+        <p:spPr/>
+        <p:txBody>
+          <a:bodyPr/>
+          <a:lstStyle/>
+          <a:p>
+            <a:r>
+              <a:t>Un mot sur le choix du modèle. J'ai entraîné trois modèles de machine learning pour deviner si une commune a une borne : la Logistic Regression, la plus simple, et deux modèles plus complexes, la Random Forest et XGBoost. Leurs scores sont quasi identiques : environ 87 % de comparaisons justes pour les trois. J'avais fixé une règle avant de voir les résultats : si l'écart est inférieur à un centième, je garde le plus simple. L'écart était de trois millièmes. La Logistic Regression est donc retenue : aussi fiable, plus lisible et plus rapide. Et la taille de la commune seule fait presque aussi bien.</a:t>
+            </a:r>
+          </a:p>
+        </p:txBody>
+      </p:sp>
+      <p:sp>
+        <p:nvSpPr>
+          <p:cNvPr id="4" name="Slide Number Placeholder 3"/>
+          <p:cNvSpPr>
+            <a:spLocks noGrp="1"/>
+          </p:cNvSpPr>
+          <p:nvPr>
+            <p:ph type="sldNum" idx="5" sz="quarter"/>
+          </p:nvPr>
+        </p:nvSpPr>
+        <p:spPr/>
+      </p:sp>
+    </p:spTree>
+  </p:cSld>
+  <p:clrMapOvr>
+    <a:masterClrMapping/>
+  </p:clrMapOvr>
+</p:notes>
+</file>
+
+<file path=ppt/notesSlides/notesSlide12.xml><?xml version="1.0" encoding="utf-8"?>
 <p:notes xmlns:a="http://schemas.openxmlformats.org/drawingml/2006/main" xmlns:p="http://schemas.openxmlformats.org/presentationml/2006/main" xmlns:r="http://schemas.openxmlformats.org/officeDocument/2006/relationships">
   <p:cSld>
     <p:spTree>
@@ -6297,6 +6550,516 @@
     <p:bg>
       <p:bgPr>
         <a:solidFill>
+          <a:srgbClr val="FFFFFF"/>
+        </a:solidFill>
+        <a:effectLst/>
+      </p:bgPr>
+    </p:bg>
+    <p:spTree>
+      <p:nvGrpSpPr>
+        <p:cNvPr id="1" name=""/>
+        <p:cNvGrpSpPr/>
+        <p:nvPr/>
+      </p:nvGrpSpPr>
+      <p:grpSpPr/>
+      <p:sp>
+        <p:nvSpPr>
+          <p:cNvPr id="2" name="Titre"/>
+          <p:cNvSpPr txBox="1"/>
+          <p:nvPr/>
+        </p:nvSpPr>
+        <p:spPr>
+          <a:xfrm>
+            <a:off x="548640" y="411480"/>
+            <a:ext cx="11064240" cy="868680"/>
+          </a:xfrm>
+          <a:prstGeom prst="rect">
+            <a:avLst/>
+          </a:prstGeom>
+          <a:noFill/>
+        </p:spPr>
+        <p:txBody>
+          <a:bodyPr wrap="square" lIns="0" rIns="0" tIns="0" bIns="0" anchor="ctr">
+            <a:spAutoFit/>
+          </a:bodyPr>
+          <a:lstStyle/>
+          <a:p>
+            <a:pPr algn="l"/>
+            <a:r>
+              <a:rPr sz="3200" b="1" i="0">
+                <a:solidFill>
+                  <a:srgbClr val="14213D"/>
+                </a:solidFill>
+                <a:latin typeface="Cambria"/>
+              </a:rPr>
+              <a:t>Trois modèles comparés : le plus simple suffit</a:t>
+            </a:r>
+          </a:p>
+        </p:txBody>
+      </p:sp>
+      <p:sp>
+        <p:nvSpPr>
+          <p:cNvPr id="3" name="Source"/>
+          <p:cNvSpPr txBox="1"/>
+          <p:nvPr/>
+        </p:nvSpPr>
+        <p:spPr>
+          <a:xfrm>
+            <a:off x="548640" y="6400800"/>
+            <a:ext cx="9601200" cy="274320"/>
+          </a:xfrm>
+          <a:prstGeom prst="rect">
+            <a:avLst/>
+          </a:prstGeom>
+          <a:noFill/>
+        </p:spPr>
+        <p:txBody>
+          <a:bodyPr wrap="square" lIns="0" rIns="0" tIns="0" bIns="0" anchor="t">
+            <a:spAutoFit/>
+          </a:bodyPr>
+          <a:lstStyle/>
+          <a:p>
+            <a:pPr algn="l"/>
+            <a:r>
+              <a:rPr sz="1000" b="0" i="0">
+                <a:solidFill>
+                  <a:srgbClr val="5B6370"/>
+                </a:solidFill>
+                <a:latin typeface="Calibri"/>
+              </a:rPr>
+              <a:t>Sources : fichier consolidé IRVE (data.gouv.fr, 31/08/2026) ; population : Base Adresse Nationale</a:t>
+            </a:r>
+          </a:p>
+        </p:txBody>
+      </p:sp>
+      <p:sp>
+        <p:nvSpPr>
+          <p:cNvPr id="4" name="Numéro"/>
+          <p:cNvSpPr txBox="1"/>
+          <p:nvPr/>
+        </p:nvSpPr>
+        <p:spPr>
+          <a:xfrm>
+            <a:off x="11155680" y="6400800"/>
+            <a:ext cx="502920" cy="274320"/>
+          </a:xfrm>
+          <a:prstGeom prst="rect">
+            <a:avLst/>
+          </a:prstGeom>
+          <a:noFill/>
+        </p:spPr>
+        <p:txBody>
+          <a:bodyPr wrap="square" lIns="0" rIns="0" tIns="0" bIns="0" anchor="t">
+            <a:spAutoFit/>
+          </a:bodyPr>
+          <a:lstStyle/>
+          <a:p>
+            <a:pPr algn="r"/>
+            <a:r>
+              <a:rPr sz="1000" b="0" i="0">
+                <a:solidFill>
+                  <a:srgbClr val="5B6370"/>
+                </a:solidFill>
+                <a:latin typeface="Calibri"/>
+              </a:rPr>
+              <a:t>11</a:t>
+            </a:r>
+          </a:p>
+        </p:txBody>
+      </p:sp>
+      <p:sp>
+        <p:nvSpPr>
+          <p:cNvPr id="5" name="TextBox 4"/>
+          <p:cNvSpPr txBox="1"/>
+          <p:nvPr/>
+        </p:nvSpPr>
+        <p:spPr>
+          <a:xfrm>
+            <a:off x="548640" y="1371600"/>
+            <a:ext cx="6035040" cy="365760"/>
+          </a:xfrm>
+          <a:prstGeom prst="rect">
+            <a:avLst/>
+          </a:prstGeom>
+          <a:noFill/>
+        </p:spPr>
+        <p:txBody>
+          <a:bodyPr wrap="square" lIns="0" rIns="0" tIns="0" bIns="0" anchor="t">
+            <a:spAutoFit/>
+          </a:bodyPr>
+          <a:lstStyle/>
+          <a:p>
+            <a:pPr algn="l"/>
+            <a:r>
+              <a:rPr sz="1500" b="0" i="0">
+                <a:solidFill>
+                  <a:srgbClr val="5B6370"/>
+                </a:solidFill>
+                <a:latin typeface="Calibri"/>
+              </a:rPr>
+              <a:t>Score sur 20 départements jamais vus par les modèles (AUC)</a:t>
+            </a:r>
+          </a:p>
+        </p:txBody>
+      </p:sp>
+      <p:graphicFrame>
+        <p:nvGraphicFramePr>
+          <p:cNvPr id="6" name="Chart 5"/>
+          <p:cNvGraphicFramePr>
+            <a:graphicFrameLocks noGrp="1"/>
+          </p:cNvGraphicFramePr>
+          <p:nvPr/>
+        </p:nvGraphicFramePr>
+        <p:xfrm>
+          <a:off x="457200" y="1737360"/>
+          <a:ext cx="6126480" cy="3291840"/>
+        </p:xfrm>
+        <a:graphic>
+          <a:graphicData uri="http://schemas.openxmlformats.org/drawingml/2006/chart">
+            <c:chart xmlns:c="http://schemas.openxmlformats.org/drawingml/2006/chart" r:id="rId3"/>
+          </a:graphicData>
+        </a:graphic>
+      </p:graphicFrame>
+      <p:sp>
+        <p:nvSpPr>
+          <p:cNvPr id="7" name="TextBox 6"/>
+          <p:cNvSpPr txBox="1"/>
+          <p:nvPr/>
+        </p:nvSpPr>
+        <p:spPr>
+          <a:xfrm>
+            <a:off x="548640" y="5166360"/>
+            <a:ext cx="6035040" cy="1005840"/>
+          </a:xfrm>
+          <a:prstGeom prst="rect">
+            <a:avLst/>
+          </a:prstGeom>
+          <a:noFill/>
+        </p:spPr>
+        <p:txBody>
+          <a:bodyPr wrap="square" lIns="0" rIns="0" tIns="0" bIns="0" anchor="t">
+            <a:spAutoFit/>
+          </a:bodyPr>
+          <a:lstStyle/>
+          <a:p>
+            <a:pPr algn="l"/>
+            <a:r>
+              <a:rPr sz="1400" b="0" i="1">
+                <a:solidFill>
+                  <a:srgbClr val="5B6370"/>
+                </a:solidFill>
+                <a:latin typeface="Calibri"/>
+              </a:rPr>
+              <a:t>AUC de 0,871 : en comparant une commune équipée et une commune sans borne, le modèle donne la bonne réponse dans 87 % des cas.</a:t>
+            </a:r>
+          </a:p>
+        </p:txBody>
+      </p:sp>
+      <p:sp>
+        <p:nvSpPr>
+          <p:cNvPr id="8" name="Rounded Rectangle 7"/>
+          <p:cNvSpPr/>
+          <p:nvPr/>
+        </p:nvSpPr>
+        <p:spPr>
+          <a:xfrm>
+            <a:off x="6949440" y="1508760"/>
+            <a:ext cx="4709160" cy="4663440"/>
+          </a:xfrm>
+          <a:prstGeom prst="roundRect">
+            <a:avLst>
+              <a:gd name="adj" fmla="val 8000"/>
+            </a:avLst>
+          </a:prstGeom>
+          <a:solidFill>
+            <a:srgbClr val="F1F4F8"/>
+          </a:solidFill>
+          <a:ln>
+            <a:noFill/>
+          </a:ln>
+          <a:effectLst/>
+        </p:spPr>
+        <p:style>
+          <a:lnRef idx="1">
+            <a:schemeClr val="accent1"/>
+          </a:lnRef>
+          <a:fillRef idx="3">
+            <a:schemeClr val="accent1"/>
+          </a:fillRef>
+          <a:effectRef idx="2">
+            <a:schemeClr val="accent1"/>
+          </a:effectRef>
+          <a:fontRef idx="minor">
+            <a:schemeClr val="lt1"/>
+          </a:fontRef>
+        </p:style>
+        <p:txBody>
+          <a:bodyPr rtlCol="0" anchor="ctr"/>
+          <a:lstStyle/>
+          <a:p>
+            <a:pPr algn="ctr"/>
+          </a:p>
+        </p:txBody>
+      </p:sp>
+      <p:sp>
+        <p:nvSpPr>
+          <p:cNvPr id="9" name="TextBox 8"/>
+          <p:cNvSpPr txBox="1"/>
+          <p:nvPr/>
+        </p:nvSpPr>
+        <p:spPr>
+          <a:xfrm>
+            <a:off x="7269480" y="1737360"/>
+            <a:ext cx="4114800" cy="457200"/>
+          </a:xfrm>
+          <a:prstGeom prst="rect">
+            <a:avLst/>
+          </a:prstGeom>
+          <a:noFill/>
+        </p:spPr>
+        <p:txBody>
+          <a:bodyPr wrap="square" lIns="0" rIns="0" tIns="0" bIns="0" anchor="t">
+            <a:spAutoFit/>
+          </a:bodyPr>
+          <a:lstStyle/>
+          <a:p>
+            <a:pPr algn="l"/>
+            <a:r>
+              <a:rPr sz="2000" b="1" i="0">
+                <a:solidFill>
+                  <a:srgbClr val="14213D"/>
+                </a:solidFill>
+                <a:latin typeface="Calibri"/>
+              </a:rPr>
+              <a:t>Pourquoi le plus simple ?</a:t>
+            </a:r>
+          </a:p>
+        </p:txBody>
+      </p:sp>
+      <p:sp>
+        <p:nvSpPr>
+          <p:cNvPr id="10" name="TextBox 9"/>
+          <p:cNvSpPr txBox="1"/>
+          <p:nvPr/>
+        </p:nvSpPr>
+        <p:spPr>
+          <a:xfrm>
+            <a:off x="7269480" y="2377440"/>
+            <a:ext cx="1371600" cy="1005840"/>
+          </a:xfrm>
+          <a:prstGeom prst="rect">
+            <a:avLst/>
+          </a:prstGeom>
+          <a:noFill/>
+        </p:spPr>
+        <p:txBody>
+          <a:bodyPr wrap="square" lIns="0" rIns="0" tIns="0" bIns="0" anchor="t">
+            <a:spAutoFit/>
+          </a:bodyPr>
+          <a:lstStyle/>
+          <a:p>
+            <a:pPr algn="l"/>
+            <a:r>
+              <a:rPr sz="2400" b="1" i="0">
+                <a:solidFill>
+                  <a:srgbClr val="2A78D6"/>
+                </a:solidFill>
+                <a:latin typeface="Calibri"/>
+              </a:rPr>
+              <a:t>0,003</a:t>
+            </a:r>
+          </a:p>
+        </p:txBody>
+      </p:sp>
+      <p:sp>
+        <p:nvSpPr>
+          <p:cNvPr id="11" name="TextBox 10"/>
+          <p:cNvSpPr txBox="1"/>
+          <p:nvPr/>
+        </p:nvSpPr>
+        <p:spPr>
+          <a:xfrm>
+            <a:off x="8686800" y="2423160"/>
+            <a:ext cx="2743200" cy="1097280"/>
+          </a:xfrm>
+          <a:prstGeom prst="rect">
+            <a:avLst/>
+          </a:prstGeom>
+          <a:noFill/>
+        </p:spPr>
+        <p:txBody>
+          <a:bodyPr wrap="square" lIns="0" rIns="0" tIns="0" bIns="0" anchor="t">
+            <a:spAutoFit/>
+          </a:bodyPr>
+          <a:lstStyle/>
+          <a:p>
+            <a:pPr algn="l"/>
+            <a:r>
+              <a:rPr sz="1500" b="0" i="0">
+                <a:solidFill>
+                  <a:srgbClr val="1F2937"/>
+                </a:solidFill>
+                <a:latin typeface="Calibri"/>
+              </a:rPr>
+              <a:t>d'écart avec le meilleur : négligeable, selon une règle fixée avant les résultats (moins de 0,01)</a:t>
+            </a:r>
+          </a:p>
+        </p:txBody>
+      </p:sp>
+      <p:sp>
+        <p:nvSpPr>
+          <p:cNvPr id="12" name="TextBox 11"/>
+          <p:cNvSpPr txBox="1"/>
+          <p:nvPr/>
+        </p:nvSpPr>
+        <p:spPr>
+          <a:xfrm>
+            <a:off x="7269480" y="3611880"/>
+            <a:ext cx="1371600" cy="1005840"/>
+          </a:xfrm>
+          <a:prstGeom prst="rect">
+            <a:avLst/>
+          </a:prstGeom>
+          <a:noFill/>
+        </p:spPr>
+        <p:txBody>
+          <a:bodyPr wrap="square" lIns="0" rIns="0" tIns="0" bIns="0" anchor="t">
+            <a:spAutoFit/>
+          </a:bodyPr>
+          <a:lstStyle/>
+          <a:p>
+            <a:pPr algn="l"/>
+            <a:r>
+              <a:rPr sz="2400" b="1" i="0">
+                <a:solidFill>
+                  <a:srgbClr val="2A78D6"/>
+                </a:solidFill>
+                <a:latin typeface="Calibri"/>
+              </a:rPr>
+              <a:t>Lisible</a:t>
+            </a:r>
+          </a:p>
+        </p:txBody>
+      </p:sp>
+      <p:sp>
+        <p:nvSpPr>
+          <p:cNvPr id="13" name="TextBox 12"/>
+          <p:cNvSpPr txBox="1"/>
+          <p:nvPr/>
+        </p:nvSpPr>
+        <p:spPr>
+          <a:xfrm>
+            <a:off x="8686800" y="3657600"/>
+            <a:ext cx="2743200" cy="1097280"/>
+          </a:xfrm>
+          <a:prstGeom prst="rect">
+            <a:avLst/>
+          </a:prstGeom>
+          <a:noFill/>
+        </p:spPr>
+        <p:txBody>
+          <a:bodyPr wrap="square" lIns="0" rIns="0" tIns="0" bIns="0" anchor="t">
+            <a:spAutoFit/>
+          </a:bodyPr>
+          <a:lstStyle/>
+          <a:p>
+            <a:pPr algn="l"/>
+            <a:r>
+              <a:rPr sz="1500" b="0" i="0">
+                <a:solidFill>
+                  <a:srgbClr val="1F2937"/>
+                </a:solidFill>
+                <a:latin typeface="Calibri"/>
+              </a:rPr>
+              <a:t>on peut expliquer le poids de chaque facteur à un élu ou à un aménageur</a:t>
+            </a:r>
+          </a:p>
+        </p:txBody>
+      </p:sp>
+      <p:sp>
+        <p:nvSpPr>
+          <p:cNvPr id="14" name="TextBox 13"/>
+          <p:cNvSpPr txBox="1"/>
+          <p:nvPr/>
+        </p:nvSpPr>
+        <p:spPr>
+          <a:xfrm>
+            <a:off x="7269480" y="4846320"/>
+            <a:ext cx="1371600" cy="1005840"/>
+          </a:xfrm>
+          <a:prstGeom prst="rect">
+            <a:avLst/>
+          </a:prstGeom>
+          <a:noFill/>
+        </p:spPr>
+        <p:txBody>
+          <a:bodyPr wrap="square" lIns="0" rIns="0" tIns="0" bIns="0" anchor="t">
+            <a:spAutoFit/>
+          </a:bodyPr>
+          <a:lstStyle/>
+          <a:p>
+            <a:pPr algn="l"/>
+            <a:r>
+              <a:rPr sz="2400" b="1" i="0">
+                <a:solidFill>
+                  <a:srgbClr val="2A78D6"/>
+                </a:solidFill>
+                <a:latin typeface="Calibri"/>
+              </a:rPr>
+              <a:t>Rapide</a:t>
+            </a:r>
+          </a:p>
+        </p:txBody>
+      </p:sp>
+      <p:sp>
+        <p:nvSpPr>
+          <p:cNvPr id="15" name="TextBox 14"/>
+          <p:cNvSpPr txBox="1"/>
+          <p:nvPr/>
+        </p:nvSpPr>
+        <p:spPr>
+          <a:xfrm>
+            <a:off x="8686800" y="4892040"/>
+            <a:ext cx="2743200" cy="1097280"/>
+          </a:xfrm>
+          <a:prstGeom prst="rect">
+            <a:avLst/>
+          </a:prstGeom>
+          <a:noFill/>
+        </p:spPr>
+        <p:txBody>
+          <a:bodyPr wrap="square" lIns="0" rIns="0" tIns="0" bIns="0" anchor="t">
+            <a:spAutoFit/>
+          </a:bodyPr>
+          <a:lstStyle/>
+          <a:p>
+            <a:pPr algn="l"/>
+            <a:r>
+              <a:rPr sz="1500" b="0" i="0">
+                <a:solidFill>
+                  <a:srgbClr val="1F2937"/>
+                </a:solidFill>
+                <a:latin typeface="Calibri"/>
+              </a:rPr>
+              <a:t>quelques secondes d'entraînement, contre plus de 30 s pour la Random Forest</a:t>
+            </a:r>
+          </a:p>
+        </p:txBody>
+      </p:sp>
+    </p:spTree>
+  </p:cSld>
+  <p:clrMapOvr>
+    <a:masterClrMapping/>
+  </p:clrMapOvr>
+</p:sld>
+</file>
+
+<file path=ppt/slides/slide12.xml><?xml version="1.0" encoding="utf-8"?>
+<p:sld xmlns:a="http://schemas.openxmlformats.org/drawingml/2006/main" xmlns:p="http://schemas.openxmlformats.org/presentationml/2006/main" xmlns:r="http://schemas.openxmlformats.org/officeDocument/2006/relationships">
+  <p:cSld>
+    <p:bg>
+      <p:bgPr>
+        <a:solidFill>
           <a:srgbClr val="14213D"/>
         </a:solidFill>
         <a:effectLst/>
@@ -6621,7 +7384,7 @@
                 </a:solidFill>
                 <a:latin typeface="Calibri"/>
               </a:rPr>
-              <a:t>11</a:t>
+              <a:t>12</a:t>
             </a:r>
           </a:p>
         </p:txBody>

</xml_diff>